<commit_message>
updated talk and images
</commit_message>
<xml_diff>
--- a/cppcon/CRG_Talk_EN.pptx
+++ b/cppcon/CRG_Talk_EN.pptx
@@ -5673,30 +5673,6 @@
           </a:p>
         </p:txBody>
       </p:sp>
-      <p:pic>
-        <p:nvPicPr>
-          <p:cNvPr id="4" name="Picture 3" descr="image.jpg"/>
-          <p:cNvPicPr>
-            <a:picLocks noChangeAspect="1"/>
-          </p:cNvPicPr>
-          <p:nvPr/>
-        </p:nvPicPr>
-        <p:blipFill>
-          <a:blip r:embed="rId2"/>
-          <a:stretch>
-            <a:fillRect/>
-          </a:stretch>
-        </p:blipFill>
-        <p:spPr>
-          <a:xfrm>
-            <a:off x="6583680" y="1645920"/>
-            <a:ext cx="5029200" cy="4303200"/>
-          </a:xfrm>
-          <a:prstGeom prst="rect">
-            <a:avLst/>
-          </a:prstGeom>
-        </p:spPr>
-      </p:pic>
     </p:spTree>
   </p:cSld>
   <p:clrMapOvr>

</xml_diff>

<commit_message>
updated talk and slides
</commit_message>
<xml_diff>
--- a/cppcon/CRG_Talk_EN.pptx
+++ b/cppcon/CRG_Talk_EN.pptx
@@ -23,6 +23,7 @@
     <p:sldId id="271" r:id="rId23"/>
     <p:sldId id="272" r:id="rId24"/>
     <p:sldId id="273" r:id="rId25"/>
+    <p:sldId id="274" r:id="rId26"/>
   </p:sldIdLst>
   <p:sldSz cx="12191695" cy="6858000" type="screen4x3"/>
   <p:notesSz cx="6858000" cy="9144000"/>
@@ -1079,7 +1080,7 @@
           <a:lstStyle/>
           <a:p>
             <a:r>
-              <a:t>At 10% mutation, ECS is 30% slower because of structural migrations. CRG stays flat because data never moves. As the dataset grows past L3 cache, ECS spikes while CRG flatlines. CRG makes data immobile, which makes it predictable for the hardware.</a:t>
+              <a:t>This is the physical reality of the Memory Wall. At a 10% mutation rate, traditional ECS architectures drop to 19 Gi/s because the CPU is busy moving memory instead of executing logic. CRG sustains over 30 Gi/s because the topology is immutable. Note the QR code on the right: you can scan it now to access the live simulator and verify these performance metrics on your own device during the Q&amp;A.</a:t>
             </a:r>
           </a:p>
         </p:txBody>
@@ -1105,6 +1106,76 @@
 </file>
 
 <file path=ppt/notesSlides/notesSlide18.xml><?xml version="1.0" encoding="utf-8"?>
+<p:notes xmlns:a="http://schemas.openxmlformats.org/drawingml/2006/main" xmlns:p="http://schemas.openxmlformats.org/presentationml/2006/main" xmlns:r="http://schemas.openxmlformats.org/officeDocument/2006/relationships">
+  <p:cSld>
+    <p:spTree>
+      <p:nvGrpSpPr>
+        <p:cNvPr id="1" name=""/>
+        <p:cNvGrpSpPr/>
+        <p:nvPr/>
+      </p:nvGrpSpPr>
+      <p:grpSpPr>
+        <a:xfrm>
+          <a:off x="0" y="0"/>
+          <a:ext cx="0" cy="0"/>
+          <a:chOff x="0" y="0"/>
+          <a:chExt cx="0" cy="0"/>
+        </a:xfrm>
+      </p:grpSpPr>
+      <p:sp>
+        <p:nvSpPr>
+          <p:cNvPr id="2" name="Slide Image Placeholder 1"/>
+          <p:cNvSpPr>
+            <a:spLocks noGrp="1"/>
+          </p:cNvSpPr>
+          <p:nvPr>
+            <p:ph type="sldImg" idx="2"/>
+          </p:nvPr>
+        </p:nvSpPr>
+        <p:spPr/>
+      </p:sp>
+      <p:sp>
+        <p:nvSpPr>
+          <p:cNvPr id="3" name="Notes Placeholder 2"/>
+          <p:cNvSpPr>
+            <a:spLocks noGrp="1"/>
+          </p:cNvSpPr>
+          <p:nvPr>
+            <p:ph type="body" idx="3" sz="quarter"/>
+          </p:nvPr>
+        </p:nvSpPr>
+        <p:spPr/>
+        <p:txBody>
+          <a:bodyPr/>
+          <a:lstStyle/>
+          <a:p>
+            <a:r>
+              <a:t>In this visual stress test at 50,000 entities, you can see the ECS frame-time (in red) skyrocketing as soon as we introduce behavioral volatility. Every archetype change is a memory copy that destroys cache locality. The green line represents CRG: it remains a flat line because it treats transitions as coordinate updates, not structural rewires. Feel free to use the simulator link to adjust the mutation rate yourself.</a:t>
+            </a:r>
+          </a:p>
+        </p:txBody>
+      </p:sp>
+      <p:sp>
+        <p:nvSpPr>
+          <p:cNvPr id="4" name="Slide Number Placeholder 3"/>
+          <p:cNvSpPr>
+            <a:spLocks noGrp="1"/>
+          </p:cNvSpPr>
+          <p:nvPr>
+            <p:ph type="sldNum" idx="5" sz="quarter"/>
+          </p:nvPr>
+        </p:nvSpPr>
+        <p:spPr/>
+      </p:sp>
+    </p:spTree>
+  </p:cSld>
+  <p:clrMapOvr>
+    <a:masterClrMapping/>
+  </p:clrMapOvr>
+</p:notes>
+</file>
+
+<file path=ppt/notesSlides/notesSlide19.xml><?xml version="1.0" encoding="utf-8"?>
 <p:notes xmlns:a="http://schemas.openxmlformats.org/drawingml/2006/main" xmlns:p="http://schemas.openxmlformats.org/presentationml/2006/main" xmlns:r="http://schemas.openxmlformats.org/officeDocument/2006/relationships">
   <p:cSld>
     <p:spTree>
@@ -4770,12 +4841,12 @@
           </a:solidFill>
         </p:spPr>
         <p:txBody>
-          <a:bodyPr wrap="square">
+          <a:bodyPr wrap="none">
             <a:spAutoFit/>
           </a:bodyPr>
           <a:lstStyle/>
           <a:p>
-            <a:pPr algn="l">
+            <a:pPr>
               <a:defRPr sz="1300">
                 <a:solidFill>
                   <a:srgbClr val="DCDCDC"/>
@@ -4788,7 +4859,7 @@
             </a:r>
           </a:p>
           <a:p>
-            <a:pPr algn="l">
+            <a:pPr>
               <a:defRPr sz="1300">
                 <a:solidFill>
                   <a:srgbClr val="DCDCDC"/>
@@ -4801,7 +4872,7 @@
             </a:r>
           </a:p>
           <a:p>
-            <a:pPr algn="l">
+            <a:pPr>
               <a:defRPr sz="1300">
                 <a:solidFill>
                   <a:srgbClr val="DCDCDC"/>
@@ -4814,17 +4885,17 @@
             </a:r>
           </a:p>
           <a:p>
-            <a:pPr algn="l">
-              <a:defRPr sz="1300">
-                <a:solidFill>
-                  <a:srgbClr val="DCDCDC"/>
-                </a:solidFill>
-                <a:latin typeface="Consolas"/>
-              </a:defRPr>
-            </a:pPr>
-          </a:p>
-          <a:p>
-            <a:pPr algn="l">
+            <a:pPr>
+              <a:defRPr sz="1300">
+                <a:solidFill>
+                  <a:srgbClr val="DCDCDC"/>
+                </a:solidFill>
+                <a:latin typeface="Consolas"/>
+              </a:defRPr>
+            </a:pPr>
+          </a:p>
+          <a:p>
+            <a:pPr>
               <a:defRPr sz="1300">
                 <a:solidFill>
                   <a:srgbClr val="DCDCDC"/>
@@ -4837,7 +4908,7 @@
             </a:r>
           </a:p>
           <a:p>
-            <a:pPr algn="l">
+            <a:pPr>
               <a:defRPr sz="1300">
                 <a:solidFill>
                   <a:srgbClr val="DCDCDC"/>
@@ -4850,7 +4921,7 @@
             </a:r>
           </a:p>
           <a:p>
-            <a:pPr algn="l">
+            <a:pPr>
               <a:defRPr sz="1300">
                 <a:solidFill>
                   <a:srgbClr val="DCDCDC"/>
@@ -4863,7 +4934,7 @@
             </a:r>
           </a:p>
           <a:p>
-            <a:pPr algn="l">
+            <a:pPr>
               <a:defRPr sz="1300">
                 <a:solidFill>
                   <a:srgbClr val="DCDCDC"/>
@@ -4876,7 +4947,7 @@
             </a:r>
           </a:p>
           <a:p>
-            <a:pPr algn="l">
+            <a:pPr>
               <a:defRPr sz="1300">
                 <a:solidFill>
                   <a:srgbClr val="DCDCDC"/>
@@ -4987,12 +5058,12 @@
           </a:solidFill>
         </p:spPr>
         <p:txBody>
-          <a:bodyPr wrap="square">
+          <a:bodyPr wrap="none">
             <a:spAutoFit/>
           </a:bodyPr>
           <a:lstStyle/>
           <a:p>
-            <a:pPr algn="l">
+            <a:pPr>
               <a:defRPr sz="1300">
                 <a:solidFill>
                   <a:srgbClr val="DCDCDC"/>
@@ -5005,7 +5076,7 @@
             </a:r>
           </a:p>
           <a:p>
-            <a:pPr algn="l">
+            <a:pPr>
               <a:defRPr sz="1300">
                 <a:solidFill>
                   <a:srgbClr val="DCDCDC"/>
@@ -5018,7 +5089,7 @@
             </a:r>
           </a:p>
           <a:p>
-            <a:pPr algn="l">
+            <a:pPr>
               <a:defRPr sz="1300">
                 <a:solidFill>
                   <a:srgbClr val="DCDCDC"/>
@@ -5031,7 +5102,7 @@
             </a:r>
           </a:p>
           <a:p>
-            <a:pPr algn="l">
+            <a:pPr>
               <a:defRPr sz="1300">
                 <a:solidFill>
                   <a:srgbClr val="DCDCDC"/>
@@ -5044,7 +5115,7 @@
             </a:r>
           </a:p>
           <a:p>
-            <a:pPr algn="l">
+            <a:pPr>
               <a:defRPr sz="1300">
                 <a:solidFill>
                   <a:srgbClr val="DCDCDC"/>
@@ -5155,12 +5226,12 @@
           </a:solidFill>
         </p:spPr>
         <p:txBody>
-          <a:bodyPr wrap="square">
+          <a:bodyPr wrap="none">
             <a:spAutoFit/>
           </a:bodyPr>
           <a:lstStyle/>
           <a:p>
-            <a:pPr algn="l">
+            <a:pPr>
               <a:defRPr sz="1300">
                 <a:solidFill>
                   <a:srgbClr val="DCDCDC"/>
@@ -5173,7 +5244,7 @@
             </a:r>
           </a:p>
           <a:p>
-            <a:pPr algn="l">
+            <a:pPr>
               <a:defRPr sz="1300">
                 <a:solidFill>
                   <a:srgbClr val="DCDCDC"/>
@@ -5186,7 +5257,7 @@
             </a:r>
           </a:p>
           <a:p>
-            <a:pPr algn="l">
+            <a:pPr>
               <a:defRPr sz="1300">
                 <a:solidFill>
                   <a:srgbClr val="DCDCDC"/>
@@ -5199,17 +5270,17 @@
             </a:r>
           </a:p>
           <a:p>
-            <a:pPr algn="l">
-              <a:defRPr sz="1300">
-                <a:solidFill>
-                  <a:srgbClr val="DCDCDC"/>
-                </a:solidFill>
-                <a:latin typeface="Consolas"/>
-              </a:defRPr>
-            </a:pPr>
-          </a:p>
-          <a:p>
-            <a:pPr algn="l">
+            <a:pPr>
+              <a:defRPr sz="1300">
+                <a:solidFill>
+                  <a:srgbClr val="DCDCDC"/>
+                </a:solidFill>
+                <a:latin typeface="Consolas"/>
+              </a:defRPr>
+            </a:pPr>
+          </a:p>
+          <a:p>
+            <a:pPr>
               <a:defRPr sz="1300">
                 <a:solidFill>
                   <a:srgbClr val="DCDCDC"/>
@@ -5222,7 +5293,7 @@
             </a:r>
           </a:p>
           <a:p>
-            <a:pPr algn="l">
+            <a:pPr>
               <a:defRPr sz="1300">
                 <a:solidFill>
                   <a:srgbClr val="DCDCDC"/>
@@ -5235,7 +5306,7 @@
             </a:r>
           </a:p>
           <a:p>
-            <a:pPr algn="l">
+            <a:pPr>
               <a:defRPr sz="1300">
                 <a:solidFill>
                   <a:srgbClr val="DCDCDC"/>
@@ -5248,7 +5319,7 @@
             </a:r>
           </a:p>
           <a:p>
-            <a:pPr algn="l">
+            <a:pPr>
               <a:defRPr sz="1300">
                 <a:solidFill>
                   <a:srgbClr val="DCDCDC"/>
@@ -5261,7 +5332,7 @@
             </a:r>
           </a:p>
           <a:p>
-            <a:pPr algn="l">
+            <a:pPr>
               <a:defRPr sz="1300">
                 <a:solidFill>
                   <a:srgbClr val="DCDCDC"/>
@@ -5274,7 +5345,7 @@
             </a:r>
           </a:p>
           <a:p>
-            <a:pPr algn="l">
+            <a:pPr>
               <a:defRPr sz="1300">
                 <a:solidFill>
                   <a:srgbClr val="DCDCDC"/>
@@ -5287,7 +5358,7 @@
             </a:r>
           </a:p>
           <a:p>
-            <a:pPr algn="l">
+            <a:pPr>
               <a:defRPr sz="1300">
                 <a:solidFill>
                   <a:srgbClr val="DCDCDC"/>
@@ -5300,7 +5371,7 @@
             </a:r>
           </a:p>
           <a:p>
-            <a:pPr algn="l">
+            <a:pPr>
               <a:defRPr sz="1300">
                 <a:solidFill>
                   <a:srgbClr val="DCDCDC"/>
@@ -5411,12 +5482,12 @@
           </a:solidFill>
         </p:spPr>
         <p:txBody>
-          <a:bodyPr wrap="square">
+          <a:bodyPr wrap="none">
             <a:spAutoFit/>
           </a:bodyPr>
           <a:lstStyle/>
           <a:p>
-            <a:pPr algn="l">
+            <a:pPr>
               <a:defRPr sz="1300">
                 <a:solidFill>
                   <a:srgbClr val="DCDCDC"/>
@@ -5429,7 +5500,7 @@
             </a:r>
           </a:p>
           <a:p>
-            <a:pPr algn="l">
+            <a:pPr>
               <a:defRPr sz="1300">
                 <a:solidFill>
                   <a:srgbClr val="DCDCDC"/>
@@ -5442,17 +5513,17 @@
             </a:r>
           </a:p>
           <a:p>
-            <a:pPr algn="l">
-              <a:defRPr sz="1300">
-                <a:solidFill>
-                  <a:srgbClr val="DCDCDC"/>
-                </a:solidFill>
-                <a:latin typeface="Consolas"/>
-              </a:defRPr>
-            </a:pPr>
-          </a:p>
-          <a:p>
-            <a:pPr algn="l">
+            <a:pPr>
+              <a:defRPr sz="1300">
+                <a:solidFill>
+                  <a:srgbClr val="DCDCDC"/>
+                </a:solidFill>
+                <a:latin typeface="Consolas"/>
+              </a:defRPr>
+            </a:pPr>
+          </a:p>
+          <a:p>
+            <a:pPr>
               <a:defRPr sz="1300">
                 <a:solidFill>
                   <a:srgbClr val="DCDCDC"/>
@@ -5465,7 +5536,7 @@
             </a:r>
           </a:p>
           <a:p>
-            <a:pPr algn="l">
+            <a:pPr>
               <a:defRPr sz="1300">
                 <a:solidFill>
                   <a:srgbClr val="DCDCDC"/>
@@ -5576,12 +5647,12 @@
           </a:solidFill>
         </p:spPr>
         <p:txBody>
-          <a:bodyPr wrap="square">
+          <a:bodyPr wrap="none">
             <a:spAutoFit/>
           </a:bodyPr>
           <a:lstStyle/>
           <a:p>
-            <a:pPr algn="l">
+            <a:pPr>
               <a:defRPr sz="1300">
                 <a:solidFill>
                   <a:srgbClr val="DCDCDC"/>
@@ -5594,7 +5665,7 @@
             </a:r>
           </a:p>
           <a:p>
-            <a:pPr algn="l">
+            <a:pPr>
               <a:defRPr sz="1300">
                 <a:solidFill>
                   <a:srgbClr val="DCDCDC"/>
@@ -5607,7 +5678,7 @@
             </a:r>
           </a:p>
           <a:p>
-            <a:pPr algn="l">
+            <a:pPr>
               <a:defRPr sz="1300">
                 <a:solidFill>
                   <a:srgbClr val="DCDCDC"/>
@@ -5620,7 +5691,7 @@
             </a:r>
           </a:p>
           <a:p>
-            <a:pPr algn="l">
+            <a:pPr>
               <a:defRPr sz="1300">
                 <a:solidFill>
                   <a:srgbClr val="DCDCDC"/>
@@ -5633,7 +5704,7 @@
             </a:r>
           </a:p>
           <a:p>
-            <a:pPr algn="l">
+            <a:pPr>
               <a:defRPr sz="1300">
                 <a:solidFill>
                   <a:srgbClr val="DCDCDC"/>
@@ -5646,7 +5717,7 @@
             </a:r>
           </a:p>
           <a:p>
-            <a:pPr algn="l">
+            <a:pPr>
               <a:defRPr sz="1300">
                 <a:solidFill>
                   <a:srgbClr val="DCDCDC"/>
@@ -5659,7 +5730,7 @@
             </a:r>
           </a:p>
           <a:p>
-            <a:pPr algn="l">
+            <a:pPr>
               <a:defRPr sz="1300">
                 <a:solidFill>
                   <a:srgbClr val="DCDCDC"/>
@@ -5746,12 +5817,12 @@
           </a:solidFill>
         </p:spPr>
         <p:txBody>
-          <a:bodyPr wrap="square">
+          <a:bodyPr wrap="none">
             <a:spAutoFit/>
           </a:bodyPr>
           <a:lstStyle/>
           <a:p>
-            <a:pPr algn="l">
+            <a:pPr>
               <a:defRPr sz="1300">
                 <a:solidFill>
                   <a:srgbClr val="DCDCDC"/>
@@ -5764,7 +5835,7 @@
             </a:r>
           </a:p>
           <a:p>
-            <a:pPr algn="l">
+            <a:pPr>
               <a:defRPr sz="1300">
                 <a:solidFill>
                   <a:srgbClr val="DCDCDC"/>
@@ -5777,17 +5848,17 @@
             </a:r>
           </a:p>
           <a:p>
-            <a:pPr algn="l">
-              <a:defRPr sz="1300">
-                <a:solidFill>
-                  <a:srgbClr val="DCDCDC"/>
-                </a:solidFill>
-                <a:latin typeface="Consolas"/>
-              </a:defRPr>
-            </a:pPr>
-          </a:p>
-          <a:p>
-            <a:pPr algn="l">
+            <a:pPr>
+              <a:defRPr sz="1300">
+                <a:solidFill>
+                  <a:srgbClr val="DCDCDC"/>
+                </a:solidFill>
+                <a:latin typeface="Consolas"/>
+              </a:defRPr>
+            </a:pPr>
+          </a:p>
+          <a:p>
+            <a:pPr>
               <a:defRPr sz="1300">
                 <a:solidFill>
                   <a:srgbClr val="DCDCDC"/>
@@ -5800,7 +5871,7 @@
             </a:r>
           </a:p>
           <a:p>
-            <a:pPr algn="l">
+            <a:pPr>
               <a:defRPr sz="1300">
                 <a:solidFill>
                   <a:srgbClr val="DCDCDC"/>
@@ -5911,12 +5982,12 @@
           </a:solidFill>
         </p:spPr>
         <p:txBody>
-          <a:bodyPr wrap="square">
+          <a:bodyPr wrap="none">
             <a:spAutoFit/>
           </a:bodyPr>
           <a:lstStyle/>
           <a:p>
-            <a:pPr algn="l">
+            <a:pPr>
               <a:defRPr sz="1300">
                 <a:solidFill>
                   <a:srgbClr val="DCDCDC"/>
@@ -5929,7 +6000,7 @@
             </a:r>
           </a:p>
           <a:p>
-            <a:pPr algn="l">
+            <a:pPr>
               <a:defRPr sz="1300">
                 <a:solidFill>
                   <a:srgbClr val="DCDCDC"/>
@@ -5942,17 +6013,17 @@
             </a:r>
           </a:p>
           <a:p>
-            <a:pPr algn="l">
-              <a:defRPr sz="1300">
-                <a:solidFill>
-                  <a:srgbClr val="DCDCDC"/>
-                </a:solidFill>
-                <a:latin typeface="Consolas"/>
-              </a:defRPr>
-            </a:pPr>
-          </a:p>
-          <a:p>
-            <a:pPr algn="l">
+            <a:pPr>
+              <a:defRPr sz="1300">
+                <a:solidFill>
+                  <a:srgbClr val="DCDCDC"/>
+                </a:solidFill>
+                <a:latin typeface="Consolas"/>
+              </a:defRPr>
+            </a:pPr>
+          </a:p>
+          <a:p>
+            <a:pPr>
               <a:defRPr sz="1300">
                 <a:solidFill>
                   <a:srgbClr val="DCDCDC"/>
@@ -5965,7 +6036,7 @@
             </a:r>
           </a:p>
           <a:p>
-            <a:pPr algn="l">
+            <a:pPr>
               <a:defRPr sz="1300">
                 <a:solidFill>
                   <a:srgbClr val="DCDCDC"/>
@@ -5978,7 +6049,7 @@
             </a:r>
           </a:p>
           <a:p>
-            <a:pPr algn="l">
+            <a:pPr>
               <a:defRPr sz="1300">
                 <a:solidFill>
                   <a:srgbClr val="DCDCDC"/>
@@ -5991,7 +6062,7 @@
             </a:r>
           </a:p>
           <a:p>
-            <a:pPr algn="l">
+            <a:pPr>
               <a:defRPr sz="1300">
                 <a:solidFill>
                   <a:srgbClr val="DCDCDC"/>
@@ -6102,12 +6173,12 @@
           </a:solidFill>
         </p:spPr>
         <p:txBody>
-          <a:bodyPr wrap="square">
+          <a:bodyPr wrap="none">
             <a:spAutoFit/>
           </a:bodyPr>
           <a:lstStyle/>
           <a:p>
-            <a:pPr algn="l">
+            <a:pPr>
               <a:defRPr sz="1300">
                 <a:solidFill>
                   <a:srgbClr val="DCDCDC"/>
@@ -6120,7 +6191,7 @@
             </a:r>
           </a:p>
           <a:p>
-            <a:pPr algn="l">
+            <a:pPr>
               <a:defRPr sz="1300">
                 <a:solidFill>
                   <a:srgbClr val="DCDCDC"/>
@@ -6133,17 +6204,17 @@
             </a:r>
           </a:p>
           <a:p>
-            <a:pPr algn="l">
-              <a:defRPr sz="1300">
-                <a:solidFill>
-                  <a:srgbClr val="DCDCDC"/>
-                </a:solidFill>
-                <a:latin typeface="Consolas"/>
-              </a:defRPr>
-            </a:pPr>
-          </a:p>
-          <a:p>
-            <a:pPr algn="l">
+            <a:pPr>
+              <a:defRPr sz="1300">
+                <a:solidFill>
+                  <a:srgbClr val="DCDCDC"/>
+                </a:solidFill>
+                <a:latin typeface="Consolas"/>
+              </a:defRPr>
+            </a:pPr>
+          </a:p>
+          <a:p>
+            <a:pPr>
               <a:defRPr sz="1300">
                 <a:solidFill>
                   <a:srgbClr val="DCDCDC"/>
@@ -6156,7 +6227,7 @@
             </a:r>
           </a:p>
           <a:p>
-            <a:pPr algn="l">
+            <a:pPr>
               <a:defRPr sz="1300">
                 <a:solidFill>
                   <a:srgbClr val="DCDCDC"/>
@@ -6169,17 +6240,17 @@
             </a:r>
           </a:p>
           <a:p>
-            <a:pPr algn="l">
-              <a:defRPr sz="1300">
-                <a:solidFill>
-                  <a:srgbClr val="DCDCDC"/>
-                </a:solidFill>
-                <a:latin typeface="Consolas"/>
-              </a:defRPr>
-            </a:pPr>
-          </a:p>
-          <a:p>
-            <a:pPr algn="l">
+            <a:pPr>
+              <a:defRPr sz="1300">
+                <a:solidFill>
+                  <a:srgbClr val="DCDCDC"/>
+                </a:solidFill>
+                <a:latin typeface="Consolas"/>
+              </a:defRPr>
+            </a:pPr>
+          </a:p>
+          <a:p>
+            <a:pPr>
               <a:defRPr sz="1300">
                 <a:solidFill>
                   <a:srgbClr val="DCDCDC"/>
@@ -6192,7 +6263,7 @@
             </a:r>
           </a:p>
           <a:p>
-            <a:pPr algn="l">
+            <a:pPr>
               <a:defRPr sz="1300">
                 <a:solidFill>
                   <a:srgbClr val="DCDCDC"/>
@@ -6284,73 +6355,9 @@
           </a:p>
         </p:txBody>
       </p:sp>
-      <p:sp>
-        <p:nvSpPr>
-          <p:cNvPr id="3" name="TextBox 2"/>
-          <p:cNvSpPr txBox="1"/>
-          <p:nvPr/>
-        </p:nvSpPr>
-        <p:spPr>
-          <a:xfrm>
-            <a:off x="457200" y="1371600"/>
-            <a:ext cx="5943600" cy="5029200"/>
-          </a:xfrm>
-          <a:prstGeom prst="rect">
-            <a:avLst/>
-          </a:prstGeom>
-          <a:solidFill>
-            <a:srgbClr val="1E1E1E"/>
-          </a:solidFill>
-        </p:spPr>
-        <p:txBody>
-          <a:bodyPr wrap="square">
-            <a:spAutoFit/>
-          </a:bodyPr>
-          <a:lstStyle/>
-          <a:p>
-            <a:pPr algn="l">
-              <a:defRPr sz="1300">
-                <a:solidFill>
-                  <a:srgbClr val="DCDCDC"/>
-                </a:solidFill>
-                <a:latin typeface="Consolas"/>
-              </a:defRPr>
-            </a:pPr>
-            <a:r>
-              <a:t>// Throughput at Scale (1M entities)</a:t>
-            </a:r>
-          </a:p>
-          <a:p>
-            <a:pPr algn="l">
-              <a:defRPr sz="1300">
-                <a:solidFill>
-                  <a:srgbClr val="DCDCDC"/>
-                </a:solidFill>
-                <a:latin typeface="Consolas"/>
-              </a:defRPr>
-            </a:pPr>
-            <a:r>
-              <a:t>// Classic ECS: 19.26 Gi/s</a:t>
-            </a:r>
-          </a:p>
-          <a:p>
-            <a:pPr algn="l">
-              <a:defRPr sz="1300">
-                <a:solidFill>
-                  <a:srgbClr val="DCDCDC"/>
-                </a:solidFill>
-                <a:latin typeface="Consolas"/>
-              </a:defRPr>
-            </a:pPr>
-            <a:r>
-              <a:t>// CRG Projection: 30.83 Gi/s</a:t>
-            </a:r>
-          </a:p>
-        </p:txBody>
-      </p:sp>
       <p:pic>
         <p:nvPicPr>
-          <p:cNvPr id="4" name="Picture 3" descr="image.jpg"/>
+          <p:cNvPr id="3" name="Picture 2" descr="crg_benchmark_final_20260501_003619.png"/>
           <p:cNvPicPr>
             <a:picLocks noChangeAspect="1"/>
           </p:cNvPicPr>
@@ -6364,14 +6371,77 @@
         </p:blipFill>
         <p:spPr>
           <a:xfrm>
-            <a:off x="6583680" y="1645920"/>
-            <a:ext cx="5029200" cy="1663652"/>
+            <a:off x="457200" y="1645920"/>
+            <a:ext cx="4114800" cy="2743200"/>
           </a:xfrm>
           <a:prstGeom prst="rect">
             <a:avLst/>
           </a:prstGeom>
         </p:spPr>
       </p:pic>
+      <p:pic>
+        <p:nvPicPr>
+          <p:cNvPr id="4" name="Picture 3" descr="simulator_qr.png"/>
+          <p:cNvPicPr>
+            <a:picLocks noChangeAspect="1"/>
+          </p:cNvPicPr>
+          <p:nvPr/>
+        </p:nvPicPr>
+        <p:blipFill>
+          <a:blip r:embed="rId3"/>
+          <a:stretch>
+            <a:fillRect/>
+          </a:stretch>
+        </p:blipFill>
+        <p:spPr>
+          <a:xfrm>
+            <a:off x="9601200" y="1645920"/>
+            <a:ext cx="2011680" cy="2011680"/>
+          </a:xfrm>
+          <a:prstGeom prst="rect">
+            <a:avLst/>
+          </a:prstGeom>
+        </p:spPr>
+      </p:pic>
+      <p:sp>
+        <p:nvSpPr>
+          <p:cNvPr id="5" name="TextBox 4"/>
+          <p:cNvSpPr txBox="1"/>
+          <p:nvPr/>
+        </p:nvSpPr>
+        <p:spPr>
+          <a:xfrm>
+            <a:off x="9601200" y="3749039"/>
+            <a:ext cx="2011680" cy="914400"/>
+          </a:xfrm>
+          <a:prstGeom prst="rect">
+            <a:avLst/>
+          </a:prstGeom>
+          <a:noFill/>
+        </p:spPr>
+        <p:txBody>
+          <a:bodyPr wrap="none">
+            <a:spAutoFit/>
+          </a:bodyPr>
+          <a:lstStyle/>
+          <a:p>
+            <a:pPr algn="ctr">
+              <a:defRPr sz="1200">
+                <a:solidFill>
+                  <a:srgbClr val="DCDCDC"/>
+                </a:solidFill>
+              </a:defRPr>
+            </a:pPr>
+            <a:r>
+              <a:t>Scan to challenge</a:t>
+            </a:r>
+            <a:br/>
+            <a:r>
+              <a:t>these results live</a:t>
+            </a:r>
+          </a:p>
+        </p:txBody>
+      </p:sp>
     </p:spTree>
   </p:cSld>
   <p:clrMapOvr>
@@ -6421,7 +6491,148 @@
               </a:defRPr>
             </a:pPr>
             <a:r>
-              <a:t>17 - CONCLUSION</a:t>
+              <a:t>17 - STRESS TEST SIMULATION (High Volatility)</a:t>
+            </a:r>
+          </a:p>
+        </p:txBody>
+      </p:sp>
+      <p:pic>
+        <p:nvPicPr>
+          <p:cNvPr id="3" name="Picture 2" descr="crg_benchmark_final_20260501_003619.png"/>
+          <p:cNvPicPr>
+            <a:picLocks noChangeAspect="1"/>
+          </p:cNvPicPr>
+          <p:nvPr/>
+        </p:nvPicPr>
+        <p:blipFill>
+          <a:blip r:embed="rId2"/>
+          <a:stretch>
+            <a:fillRect/>
+          </a:stretch>
+        </p:blipFill>
+        <p:spPr>
+          <a:xfrm>
+            <a:off x="457200" y="1645920"/>
+            <a:ext cx="4114800" cy="2743200"/>
+          </a:xfrm>
+          <a:prstGeom prst="rect">
+            <a:avLst/>
+          </a:prstGeom>
+        </p:spPr>
+      </p:pic>
+      <p:pic>
+        <p:nvPicPr>
+          <p:cNvPr id="4" name="Picture 3" descr="simulator_qr.png"/>
+          <p:cNvPicPr>
+            <a:picLocks noChangeAspect="1"/>
+          </p:cNvPicPr>
+          <p:nvPr/>
+        </p:nvPicPr>
+        <p:blipFill>
+          <a:blip r:embed="rId3"/>
+          <a:stretch>
+            <a:fillRect/>
+          </a:stretch>
+        </p:blipFill>
+        <p:spPr>
+          <a:xfrm>
+            <a:off x="9601200" y="1645920"/>
+            <a:ext cx="2011680" cy="2011680"/>
+          </a:xfrm>
+          <a:prstGeom prst="rect">
+            <a:avLst/>
+          </a:prstGeom>
+        </p:spPr>
+      </p:pic>
+      <p:sp>
+        <p:nvSpPr>
+          <p:cNvPr id="5" name="TextBox 4"/>
+          <p:cNvSpPr txBox="1"/>
+          <p:nvPr/>
+        </p:nvSpPr>
+        <p:spPr>
+          <a:xfrm>
+            <a:off x="9601200" y="3749039"/>
+            <a:ext cx="2011680" cy="914400"/>
+          </a:xfrm>
+          <a:prstGeom prst="rect">
+            <a:avLst/>
+          </a:prstGeom>
+          <a:noFill/>
+        </p:spPr>
+        <p:txBody>
+          <a:bodyPr wrap="none">
+            <a:spAutoFit/>
+          </a:bodyPr>
+          <a:lstStyle/>
+          <a:p>
+            <a:pPr algn="ctr">
+              <a:defRPr sz="1200">
+                <a:solidFill>
+                  <a:srgbClr val="DCDCDC"/>
+                </a:solidFill>
+              </a:defRPr>
+            </a:pPr>
+            <a:r>
+              <a:t>Scan to challenge</a:t>
+            </a:r>
+            <a:br/>
+            <a:r>
+              <a:t>these results live</a:t>
+            </a:r>
+          </a:p>
+        </p:txBody>
+      </p:sp>
+    </p:spTree>
+  </p:cSld>
+  <p:clrMapOvr>
+    <a:masterClrMapping/>
+  </p:clrMapOvr>
+</p:sld>
+</file>
+
+<file path=ppt/slides/slide19.xml><?xml version="1.0" encoding="utf-8"?>
+<p:sld xmlns:a="http://schemas.openxmlformats.org/drawingml/2006/main" xmlns:p="http://schemas.openxmlformats.org/presentationml/2006/main" xmlns:r="http://schemas.openxmlformats.org/officeDocument/2006/relationships">
+  <p:cSld>
+    <p:bg>
+      <p:bgPr>
+        <a:solidFill>
+          <a:srgbClr val="0F0F0F"/>
+        </a:solidFill>
+        <a:effectLst/>
+      </p:bgPr>
+    </p:bg>
+    <p:spTree>
+      <p:nvGrpSpPr>
+        <p:cNvPr id="1" name=""/>
+        <p:cNvGrpSpPr/>
+        <p:nvPr/>
+      </p:nvGrpSpPr>
+      <p:grpSpPr/>
+      <p:sp>
+        <p:nvSpPr>
+          <p:cNvPr id="2" name="Title 1"/>
+          <p:cNvSpPr>
+            <a:spLocks noGrp="1"/>
+          </p:cNvSpPr>
+          <p:nvPr>
+            <p:ph type="title"/>
+          </p:nvPr>
+        </p:nvSpPr>
+        <p:spPr/>
+        <p:txBody>
+          <a:bodyPr/>
+          <a:lstStyle/>
+          <a:p>
+            <a:pPr>
+              <a:defRPr sz="3600">
+                <a:solidFill>
+                  <a:srgbClr val="6496FF"/>
+                </a:solidFill>
+              </a:defRPr>
+            </a:pPr>
+            <a:r>
+              <a:t>18 - CONCLUSION</a:t>
             </a:r>
           </a:p>
         </p:txBody>
@@ -6445,12 +6656,12 @@
           </a:solidFill>
         </p:spPr>
         <p:txBody>
-          <a:bodyPr wrap="square">
+          <a:bodyPr wrap="none">
             <a:spAutoFit/>
           </a:bodyPr>
           <a:lstStyle/>
           <a:p>
-            <a:pPr algn="l">
+            <a:pPr>
               <a:defRPr sz="1300">
                 <a:solidFill>
                   <a:srgbClr val="DCDCDC"/>
@@ -6463,7 +6674,7 @@
             </a:r>
           </a:p>
           <a:p>
-            <a:pPr algn="l">
+            <a:pPr>
               <a:defRPr sz="1300">
                 <a:solidFill>
                   <a:srgbClr val="DCDCDC"/>
@@ -6476,7 +6687,7 @@
             </a:r>
           </a:p>
           <a:p>
-            <a:pPr algn="l">
+            <a:pPr>
               <a:defRPr sz="1300">
                 <a:solidFill>
                   <a:srgbClr val="DCDCDC"/>
@@ -6489,17 +6700,17 @@
             </a:r>
           </a:p>
           <a:p>
-            <a:pPr algn="l">
-              <a:defRPr sz="1300">
-                <a:solidFill>
-                  <a:srgbClr val="DCDCDC"/>
-                </a:solidFill>
-                <a:latin typeface="Consolas"/>
-              </a:defRPr>
-            </a:pPr>
-          </a:p>
-          <a:p>
-            <a:pPr algn="l">
+            <a:pPr>
+              <a:defRPr sz="1300">
+                <a:solidFill>
+                  <a:srgbClr val="DCDCDC"/>
+                </a:solidFill>
+                <a:latin typeface="Consolas"/>
+              </a:defRPr>
+            </a:pPr>
+          </a:p>
+          <a:p>
+            <a:pPr>
               <a:defRPr sz="1300">
                 <a:solidFill>
                   <a:srgbClr val="DCDCDC"/>
@@ -6512,7 +6723,7 @@
             </a:r>
           </a:p>
           <a:p>
-            <a:pPr algn="l">
+            <a:pPr>
               <a:defRPr sz="1300">
                 <a:solidFill>
                   <a:srgbClr val="DCDCDC"/>
@@ -6623,12 +6834,12 @@
           </a:solidFill>
         </p:spPr>
         <p:txBody>
-          <a:bodyPr wrap="square">
+          <a:bodyPr wrap="none">
             <a:spAutoFit/>
           </a:bodyPr>
           <a:lstStyle/>
           <a:p>
-            <a:pPr algn="l">
+            <a:pPr>
               <a:defRPr sz="1300">
                 <a:solidFill>
                   <a:srgbClr val="DCDCDC"/>
@@ -6641,7 +6852,7 @@
             </a:r>
           </a:p>
           <a:p>
-            <a:pPr algn="l">
+            <a:pPr>
               <a:defRPr sz="1300">
                 <a:solidFill>
                   <a:srgbClr val="DCDCDC"/>
@@ -6654,7 +6865,7 @@
             </a:r>
           </a:p>
           <a:p>
-            <a:pPr algn="l">
+            <a:pPr>
               <a:defRPr sz="1300">
                 <a:solidFill>
                   <a:srgbClr val="DCDCDC"/>
@@ -6667,7 +6878,7 @@
             </a:r>
           </a:p>
           <a:p>
-            <a:pPr algn="l">
+            <a:pPr>
               <a:defRPr sz="1300">
                 <a:solidFill>
                   <a:srgbClr val="DCDCDC"/>
@@ -6680,17 +6891,17 @@
             </a:r>
           </a:p>
           <a:p>
-            <a:pPr algn="l">
-              <a:defRPr sz="1300">
-                <a:solidFill>
-                  <a:srgbClr val="DCDCDC"/>
-                </a:solidFill>
-                <a:latin typeface="Consolas"/>
-              </a:defRPr>
-            </a:pPr>
-          </a:p>
-          <a:p>
-            <a:pPr algn="l">
+            <a:pPr>
+              <a:defRPr sz="1300">
+                <a:solidFill>
+                  <a:srgbClr val="DCDCDC"/>
+                </a:solidFill>
+                <a:latin typeface="Consolas"/>
+              </a:defRPr>
+            </a:pPr>
+          </a:p>
+          <a:p>
+            <a:pPr>
               <a:defRPr sz="1300">
                 <a:solidFill>
                   <a:srgbClr val="DCDCDC"/>
@@ -6703,7 +6914,7 @@
             </a:r>
           </a:p>
           <a:p>
-            <a:pPr algn="l">
+            <a:pPr>
               <a:defRPr sz="1300">
                 <a:solidFill>
                   <a:srgbClr val="DCDCDC"/>
@@ -6716,7 +6927,7 @@
             </a:r>
           </a:p>
           <a:p>
-            <a:pPr algn="l">
+            <a:pPr>
               <a:defRPr sz="1300">
                 <a:solidFill>
                   <a:srgbClr val="DCDCDC"/>
@@ -6827,12 +7038,12 @@
           </a:solidFill>
         </p:spPr>
         <p:txBody>
-          <a:bodyPr wrap="square">
+          <a:bodyPr wrap="none">
             <a:spAutoFit/>
           </a:bodyPr>
           <a:lstStyle/>
           <a:p>
-            <a:pPr algn="l">
+            <a:pPr>
               <a:defRPr sz="1300">
                 <a:solidFill>
                   <a:srgbClr val="DCDCDC"/>
@@ -6845,7 +7056,7 @@
             </a:r>
           </a:p>
           <a:p>
-            <a:pPr algn="l">
+            <a:pPr>
               <a:defRPr sz="1300">
                 <a:solidFill>
                   <a:srgbClr val="DCDCDC"/>
@@ -6858,7 +7069,7 @@
             </a:r>
           </a:p>
           <a:p>
-            <a:pPr algn="l">
+            <a:pPr>
               <a:defRPr sz="1300">
                 <a:solidFill>
                   <a:srgbClr val="DCDCDC"/>
@@ -6871,17 +7082,17 @@
             </a:r>
           </a:p>
           <a:p>
-            <a:pPr algn="l">
-              <a:defRPr sz="1300">
-                <a:solidFill>
-                  <a:srgbClr val="DCDCDC"/>
-                </a:solidFill>
-                <a:latin typeface="Consolas"/>
-              </a:defRPr>
-            </a:pPr>
-          </a:p>
-          <a:p>
-            <a:pPr algn="l">
+            <a:pPr>
+              <a:defRPr sz="1300">
+                <a:solidFill>
+                  <a:srgbClr val="DCDCDC"/>
+                </a:solidFill>
+                <a:latin typeface="Consolas"/>
+              </a:defRPr>
+            </a:pPr>
+          </a:p>
+          <a:p>
+            <a:pPr>
               <a:defRPr sz="1300">
                 <a:solidFill>
                   <a:srgbClr val="DCDCDC"/>
@@ -6894,7 +7105,7 @@
             </a:r>
           </a:p>
           <a:p>
-            <a:pPr algn="l">
+            <a:pPr>
               <a:defRPr sz="1300">
                 <a:solidFill>
                   <a:srgbClr val="DCDCDC"/>
@@ -6907,7 +7118,7 @@
             </a:r>
           </a:p>
           <a:p>
-            <a:pPr algn="l">
+            <a:pPr>
               <a:defRPr sz="1300">
                 <a:solidFill>
                   <a:srgbClr val="DCDCDC"/>
@@ -6920,7 +7131,7 @@
             </a:r>
           </a:p>
           <a:p>
-            <a:pPr algn="l">
+            <a:pPr>
               <a:defRPr sz="1300">
                 <a:solidFill>
                   <a:srgbClr val="DCDCDC"/>
@@ -6933,7 +7144,7 @@
             </a:r>
           </a:p>
           <a:p>
-            <a:pPr algn="l">
+            <a:pPr>
               <a:defRPr sz="1300">
                 <a:solidFill>
                   <a:srgbClr val="DCDCDC"/>
@@ -7044,12 +7255,12 @@
           </a:solidFill>
         </p:spPr>
         <p:txBody>
-          <a:bodyPr wrap="square">
+          <a:bodyPr wrap="none">
             <a:spAutoFit/>
           </a:bodyPr>
           <a:lstStyle/>
           <a:p>
-            <a:pPr algn="l">
+            <a:pPr>
               <a:defRPr sz="1300">
                 <a:solidFill>
                   <a:srgbClr val="DCDCDC"/>
@@ -7062,7 +7273,7 @@
             </a:r>
           </a:p>
           <a:p>
-            <a:pPr algn="l">
+            <a:pPr>
               <a:defRPr sz="1300">
                 <a:solidFill>
                   <a:srgbClr val="DCDCDC"/>
@@ -7075,7 +7286,7 @@
             </a:r>
           </a:p>
           <a:p>
-            <a:pPr algn="l">
+            <a:pPr>
               <a:defRPr sz="1300">
                 <a:solidFill>
                   <a:srgbClr val="DCDCDC"/>
@@ -7088,7 +7299,7 @@
             </a:r>
           </a:p>
           <a:p>
-            <a:pPr algn="l">
+            <a:pPr>
               <a:defRPr sz="1300">
                 <a:solidFill>
                   <a:srgbClr val="DCDCDC"/>
@@ -7101,17 +7312,17 @@
             </a:r>
           </a:p>
           <a:p>
-            <a:pPr algn="l">
-              <a:defRPr sz="1300">
-                <a:solidFill>
-                  <a:srgbClr val="DCDCDC"/>
-                </a:solidFill>
-                <a:latin typeface="Consolas"/>
-              </a:defRPr>
-            </a:pPr>
-          </a:p>
-          <a:p>
-            <a:pPr algn="l">
+            <a:pPr>
+              <a:defRPr sz="1300">
+                <a:solidFill>
+                  <a:srgbClr val="DCDCDC"/>
+                </a:solidFill>
+                <a:latin typeface="Consolas"/>
+              </a:defRPr>
+            </a:pPr>
+          </a:p>
+          <a:p>
+            <a:pPr>
               <a:defRPr sz="1300">
                 <a:solidFill>
                   <a:srgbClr val="DCDCDC"/>
@@ -7124,7 +7335,7 @@
             </a:r>
           </a:p>
           <a:p>
-            <a:pPr algn="l">
+            <a:pPr>
               <a:defRPr sz="1300">
                 <a:solidFill>
                   <a:srgbClr val="DCDCDC"/>
@@ -7137,7 +7348,7 @@
             </a:r>
           </a:p>
           <a:p>
-            <a:pPr algn="l">
+            <a:pPr>
               <a:defRPr sz="1300">
                 <a:solidFill>
                   <a:srgbClr val="DCDCDC"/>
@@ -7248,12 +7459,12 @@
           </a:solidFill>
         </p:spPr>
         <p:txBody>
-          <a:bodyPr wrap="square">
+          <a:bodyPr wrap="none">
             <a:spAutoFit/>
           </a:bodyPr>
           <a:lstStyle/>
           <a:p>
-            <a:pPr algn="l">
+            <a:pPr>
               <a:defRPr sz="1300">
                 <a:solidFill>
                   <a:srgbClr val="DCDCDC"/>
@@ -7266,7 +7477,7 @@
             </a:r>
           </a:p>
           <a:p>
-            <a:pPr algn="l">
+            <a:pPr>
               <a:defRPr sz="1300">
                 <a:solidFill>
                   <a:srgbClr val="DCDCDC"/>
@@ -7279,7 +7490,7 @@
             </a:r>
           </a:p>
           <a:p>
-            <a:pPr algn="l">
+            <a:pPr>
               <a:defRPr sz="1300">
                 <a:solidFill>
                   <a:srgbClr val="DCDCDC"/>
@@ -7292,7 +7503,7 @@
             </a:r>
           </a:p>
           <a:p>
-            <a:pPr algn="l">
+            <a:pPr>
               <a:defRPr sz="1300">
                 <a:solidFill>
                   <a:srgbClr val="DCDCDC"/>
@@ -7305,7 +7516,7 @@
             </a:r>
           </a:p>
           <a:p>
-            <a:pPr algn="l">
+            <a:pPr>
               <a:defRPr sz="1300">
                 <a:solidFill>
                   <a:srgbClr val="DCDCDC"/>
@@ -7318,7 +7529,7 @@
             </a:r>
           </a:p>
           <a:p>
-            <a:pPr algn="l">
+            <a:pPr>
               <a:defRPr sz="1300">
                 <a:solidFill>
                   <a:srgbClr val="DCDCDC"/>
@@ -7331,7 +7542,7 @@
             </a:r>
           </a:p>
           <a:p>
-            <a:pPr algn="l">
+            <a:pPr>
               <a:defRPr sz="1300">
                 <a:solidFill>
                   <a:srgbClr val="DCDCDC"/>
@@ -7344,7 +7555,7 @@
             </a:r>
           </a:p>
           <a:p>
-            <a:pPr algn="l">
+            <a:pPr>
               <a:defRPr sz="1300">
                 <a:solidFill>
                   <a:srgbClr val="DCDCDC"/>
@@ -7357,7 +7568,7 @@
             </a:r>
           </a:p>
           <a:p>
-            <a:pPr algn="l">
+            <a:pPr>
               <a:defRPr sz="1300">
                 <a:solidFill>
                   <a:srgbClr val="DCDCDC"/>
@@ -7468,12 +7679,12 @@
           </a:solidFill>
         </p:spPr>
         <p:txBody>
-          <a:bodyPr wrap="square">
+          <a:bodyPr wrap="none">
             <a:spAutoFit/>
           </a:bodyPr>
           <a:lstStyle/>
           <a:p>
-            <a:pPr algn="l">
+            <a:pPr>
               <a:defRPr sz="1300">
                 <a:solidFill>
                   <a:srgbClr val="DCDCDC"/>
@@ -7486,7 +7697,7 @@
             </a:r>
           </a:p>
           <a:p>
-            <a:pPr algn="l">
+            <a:pPr>
               <a:defRPr sz="1300">
                 <a:solidFill>
                   <a:srgbClr val="DCDCDC"/>
@@ -7499,7 +7710,7 @@
             </a:r>
           </a:p>
           <a:p>
-            <a:pPr algn="l">
+            <a:pPr>
               <a:defRPr sz="1300">
                 <a:solidFill>
                   <a:srgbClr val="DCDCDC"/>
@@ -7512,7 +7723,7 @@
             </a:r>
           </a:p>
           <a:p>
-            <a:pPr algn="l">
+            <a:pPr>
               <a:defRPr sz="1300">
                 <a:solidFill>
                   <a:srgbClr val="DCDCDC"/>
@@ -7525,17 +7736,17 @@
             </a:r>
           </a:p>
           <a:p>
-            <a:pPr algn="l">
-              <a:defRPr sz="1300">
-                <a:solidFill>
-                  <a:srgbClr val="DCDCDC"/>
-                </a:solidFill>
-                <a:latin typeface="Consolas"/>
-              </a:defRPr>
-            </a:pPr>
-          </a:p>
-          <a:p>
-            <a:pPr algn="l">
+            <a:pPr>
+              <a:defRPr sz="1300">
+                <a:solidFill>
+                  <a:srgbClr val="DCDCDC"/>
+                </a:solidFill>
+                <a:latin typeface="Consolas"/>
+              </a:defRPr>
+            </a:pPr>
+          </a:p>
+          <a:p>
+            <a:pPr>
               <a:defRPr sz="1300">
                 <a:solidFill>
                   <a:srgbClr val="DCDCDC"/>
@@ -7548,7 +7759,7 @@
             </a:r>
           </a:p>
           <a:p>
-            <a:pPr algn="l">
+            <a:pPr>
               <a:defRPr sz="1300">
                 <a:solidFill>
                   <a:srgbClr val="DCDCDC"/>
@@ -7561,7 +7772,7 @@
             </a:r>
           </a:p>
           <a:p>
-            <a:pPr algn="l">
+            <a:pPr>
               <a:defRPr sz="1300">
                 <a:solidFill>
                   <a:srgbClr val="DCDCDC"/>
@@ -7574,7 +7785,7 @@
             </a:r>
           </a:p>
           <a:p>
-            <a:pPr algn="l">
+            <a:pPr>
               <a:defRPr sz="1300">
                 <a:solidFill>
                   <a:srgbClr val="DCDCDC"/>
@@ -7587,7 +7798,7 @@
             </a:r>
           </a:p>
           <a:p>
-            <a:pPr algn="l">
+            <a:pPr>
               <a:defRPr sz="1300">
                 <a:solidFill>
                   <a:srgbClr val="DCDCDC"/>
@@ -7600,7 +7811,7 @@
             </a:r>
           </a:p>
           <a:p>
-            <a:pPr algn="l">
+            <a:pPr>
               <a:defRPr sz="1300">
                 <a:solidFill>
                   <a:srgbClr val="DCDCDC"/>
@@ -7711,12 +7922,12 @@
           </a:solidFill>
         </p:spPr>
         <p:txBody>
-          <a:bodyPr wrap="square">
+          <a:bodyPr wrap="none">
             <a:spAutoFit/>
           </a:bodyPr>
           <a:lstStyle/>
           <a:p>
-            <a:pPr algn="l">
+            <a:pPr>
               <a:defRPr sz="1300">
                 <a:solidFill>
                   <a:srgbClr val="DCDCDC"/>
@@ -7729,7 +7940,7 @@
             </a:r>
           </a:p>
           <a:p>
-            <a:pPr algn="l">
+            <a:pPr>
               <a:defRPr sz="1300">
                 <a:solidFill>
                   <a:srgbClr val="DCDCDC"/>
@@ -7742,17 +7953,17 @@
             </a:r>
           </a:p>
           <a:p>
-            <a:pPr algn="l">
-              <a:defRPr sz="1300">
-                <a:solidFill>
-                  <a:srgbClr val="DCDCDC"/>
-                </a:solidFill>
-                <a:latin typeface="Consolas"/>
-              </a:defRPr>
-            </a:pPr>
-          </a:p>
-          <a:p>
-            <a:pPr algn="l">
+            <a:pPr>
+              <a:defRPr sz="1300">
+                <a:solidFill>
+                  <a:srgbClr val="DCDCDC"/>
+                </a:solidFill>
+                <a:latin typeface="Consolas"/>
+              </a:defRPr>
+            </a:pPr>
+          </a:p>
+          <a:p>
+            <a:pPr>
               <a:defRPr sz="1300">
                 <a:solidFill>
                   <a:srgbClr val="DCDCDC"/>
@@ -7765,7 +7976,7 @@
             </a:r>
           </a:p>
           <a:p>
-            <a:pPr algn="l">
+            <a:pPr>
               <a:defRPr sz="1300">
                 <a:solidFill>
                   <a:srgbClr val="DCDCDC"/>
@@ -7778,7 +7989,7 @@
             </a:r>
           </a:p>
           <a:p>
-            <a:pPr algn="l">
+            <a:pPr>
               <a:defRPr sz="1300">
                 <a:solidFill>
                   <a:srgbClr val="DCDCDC"/>
@@ -7791,7 +8002,7 @@
             </a:r>
           </a:p>
           <a:p>
-            <a:pPr algn="l">
+            <a:pPr>
               <a:defRPr sz="1300">
                 <a:solidFill>
                   <a:srgbClr val="DCDCDC"/>
@@ -7804,17 +8015,17 @@
             </a:r>
           </a:p>
           <a:p>
-            <a:pPr algn="l">
-              <a:defRPr sz="1300">
-                <a:solidFill>
-                  <a:srgbClr val="DCDCDC"/>
-                </a:solidFill>
-                <a:latin typeface="Consolas"/>
-              </a:defRPr>
-            </a:pPr>
-          </a:p>
-          <a:p>
-            <a:pPr algn="l">
+            <a:pPr>
+              <a:defRPr sz="1300">
+                <a:solidFill>
+                  <a:srgbClr val="DCDCDC"/>
+                </a:solidFill>
+                <a:latin typeface="Consolas"/>
+              </a:defRPr>
+            </a:pPr>
+          </a:p>
+          <a:p>
+            <a:pPr>
               <a:defRPr sz="1300">
                 <a:solidFill>
                   <a:srgbClr val="DCDCDC"/>
@@ -7827,7 +8038,7 @@
             </a:r>
           </a:p>
           <a:p>
-            <a:pPr algn="l">
+            <a:pPr>
               <a:defRPr sz="1300">
                 <a:solidFill>
                   <a:srgbClr val="DCDCDC"/>
@@ -7938,12 +8149,12 @@
           </a:solidFill>
         </p:spPr>
         <p:txBody>
-          <a:bodyPr wrap="square">
+          <a:bodyPr wrap="none">
             <a:spAutoFit/>
           </a:bodyPr>
           <a:lstStyle/>
           <a:p>
-            <a:pPr algn="l">
+            <a:pPr>
               <a:defRPr sz="1300">
                 <a:solidFill>
                   <a:srgbClr val="DCDCDC"/>
@@ -7956,7 +8167,7 @@
             </a:r>
           </a:p>
           <a:p>
-            <a:pPr algn="l">
+            <a:pPr>
               <a:defRPr sz="1300">
                 <a:solidFill>
                   <a:srgbClr val="DCDCDC"/>
@@ -7969,17 +8180,17 @@
             </a:r>
           </a:p>
           <a:p>
-            <a:pPr algn="l">
-              <a:defRPr sz="1300">
-                <a:solidFill>
-                  <a:srgbClr val="DCDCDC"/>
-                </a:solidFill>
-                <a:latin typeface="Consolas"/>
-              </a:defRPr>
-            </a:pPr>
-          </a:p>
-          <a:p>
-            <a:pPr algn="l">
+            <a:pPr>
+              <a:defRPr sz="1300">
+                <a:solidFill>
+                  <a:srgbClr val="DCDCDC"/>
+                </a:solidFill>
+                <a:latin typeface="Consolas"/>
+              </a:defRPr>
+            </a:pPr>
+          </a:p>
+          <a:p>
+            <a:pPr>
               <a:defRPr sz="1300">
                 <a:solidFill>
                   <a:srgbClr val="DCDCDC"/>
@@ -7992,7 +8203,7 @@
             </a:r>
           </a:p>
           <a:p>
-            <a:pPr algn="l">
+            <a:pPr>
               <a:defRPr sz="1300">
                 <a:solidFill>
                   <a:srgbClr val="DCDCDC"/>
@@ -8005,7 +8216,7 @@
             </a:r>
           </a:p>
           <a:p>
-            <a:pPr algn="l">
+            <a:pPr>
               <a:defRPr sz="1300">
                 <a:solidFill>
                   <a:srgbClr val="DCDCDC"/>
@@ -8018,7 +8229,7 @@
             </a:r>
           </a:p>
           <a:p>
-            <a:pPr algn="l">
+            <a:pPr>
               <a:defRPr sz="1300">
                 <a:solidFill>
                   <a:srgbClr val="DCDCDC"/>
@@ -8031,7 +8242,7 @@
             </a:r>
           </a:p>
           <a:p>
-            <a:pPr algn="l">
+            <a:pPr>
               <a:defRPr sz="1300">
                 <a:solidFill>
                   <a:srgbClr val="DCDCDC"/>
@@ -8142,12 +8353,12 @@
           </a:solidFill>
         </p:spPr>
         <p:txBody>
-          <a:bodyPr wrap="square">
+          <a:bodyPr wrap="none">
             <a:spAutoFit/>
           </a:bodyPr>
           <a:lstStyle/>
           <a:p>
-            <a:pPr algn="l">
+            <a:pPr>
               <a:defRPr sz="1300">
                 <a:solidFill>
                   <a:srgbClr val="DCDCDC"/>
@@ -8160,17 +8371,17 @@
             </a:r>
           </a:p>
           <a:p>
-            <a:pPr algn="l">
-              <a:defRPr sz="1300">
-                <a:solidFill>
-                  <a:srgbClr val="DCDCDC"/>
-                </a:solidFill>
-                <a:latin typeface="Consolas"/>
-              </a:defRPr>
-            </a:pPr>
-          </a:p>
-          <a:p>
-            <a:pPr algn="l">
+            <a:pPr>
+              <a:defRPr sz="1300">
+                <a:solidFill>
+                  <a:srgbClr val="DCDCDC"/>
+                </a:solidFill>
+                <a:latin typeface="Consolas"/>
+              </a:defRPr>
+            </a:pPr>
+          </a:p>
+          <a:p>
+            <a:pPr>
               <a:defRPr sz="1300">
                 <a:solidFill>
                   <a:srgbClr val="DCDCDC"/>
@@ -8183,7 +8394,7 @@
             </a:r>
           </a:p>
           <a:p>
-            <a:pPr algn="l">
+            <a:pPr>
               <a:defRPr sz="1300">
                 <a:solidFill>
                   <a:srgbClr val="DCDCDC"/>

</xml_diff>